<commit_message>
docs: deck team roles match the README
</commit_message>
<xml_diff>
--- a/docs/PRISM-Engine.pptx
+++ b/docs/PRISM-Engine.pptx
@@ -9144,7 +9144,7 @@
                 </a:solidFill>
                 <a:latin typeface="Calibri"/>
               </a:rPr>
-              <a:t>Frontend</a:t>
+              <a:t>Complete frontend</a:t>
             </a:r>
           </a:p>
         </p:txBody>
@@ -9396,7 +9396,7 @@
                 </a:solidFill>
                 <a:latin typeface="Calibri"/>
               </a:rPr>
-              <a:t>Early database work</a:t>
+              <a:t>Database work</a:t>
             </a:r>
           </a:p>
         </p:txBody>

</xml_diff>

<commit_message>
feat: stream-aware catalog with 56 careers, 59 programmes and 355 colleges
- db/data/*.csv: curated careers, degree programmes (eligible and natural
  Class 11-12 streams per regulator), 355 colleges with NIRF 2025 tiers,
  and fee sources (official where found, otherwise flagged estimates).
- db/scripts/build_catalog.py validates the catalog and generates seed 02;
  O*NET weights read careers.csv; market rows for the 43 new careers.
- Migration 004: profiles.stream, courses eligible/primary streams,
  exams_colleges.tier; SQL tests for the new rules.
- Backend: step 0 stream rule (own stream first, closed careers left out),
  cost at a typical (median) college, colleges shown 4 per tier;
  StudentProfile.stream required; stream_match / typical_college / tier.
- Frontend: stream question on onboarding, "Outside your stream" badge,
  colleges grouped by tier with course and city.
- Docs: guide section 4 (steps 0, 3, 5), README data section, deck.
</commit_message>
<xml_diff>
--- a/docs/PRISM-Engine.pptx
+++ b/docs/PRISM-Engine.pptx
@@ -655,7 +655,7 @@
           <a:lstStyle/>
           <a:p>
             <a:r>
-              <a:t>All counts come from the live database, the API contract and the test run on 8 October 2026.</a:t>
+              <a:t>All counts come from the catalog build, the API contract and the test run on 8 October 2026.</a:t>
             </a:r>
           </a:p>
         </p:txBody>
@@ -6201,7 +6201,7 @@
                 </a:solidFill>
                 <a:latin typeface="Calibri"/>
               </a:rPr>
-              <a:t>13</a:t>
+              <a:t>56</a:t>
             </a:r>
           </a:p>
         </p:txBody>
@@ -6327,7 +6327,7 @@
                 </a:solidFill>
                 <a:latin typeface="Calibri"/>
               </a:rPr>
-              <a:t>8</a:t>
+              <a:t>6</a:t>
             </a:r>
           </a:p>
         </p:txBody>
@@ -6366,7 +6366,7 @@
                 </a:solidFill>
                 <a:latin typeface="Calibri"/>
               </a:rPr>
-              <a:t>career areas</a:t>
+              <a:t>Class 11-12 streams</a:t>
             </a:r>
           </a:p>
         </p:txBody>
@@ -6453,7 +6453,7 @@
                 </a:solidFill>
                 <a:latin typeface="Calibri"/>
               </a:rPr>
-              <a:t>28</a:t>
+              <a:t>59</a:t>
             </a:r>
           </a:p>
         </p:txBody>
@@ -6492,7 +6492,7 @@
                 </a:solidFill>
                 <a:latin typeface="Calibri"/>
               </a:rPr>
-              <a:t>degree routes</a:t>
+              <a:t>degree programmes</a:t>
             </a:r>
           </a:p>
         </p:txBody>
@@ -6579,7 +6579,7 @@
                 </a:solidFill>
                 <a:latin typeface="Calibri"/>
               </a:rPr>
-              <a:t>29</a:t>
+              <a:t>355</a:t>
             </a:r>
           </a:p>
         </p:txBody>
@@ -6618,7 +6618,7 @@
                 </a:solidFill>
                 <a:latin typeface="Calibri"/>
               </a:rPr>
-              <a:t>entrance exams</a:t>
+              <a:t>colleges in 3 NIRF tiers</a:t>
             </a:r>
           </a:p>
         </p:txBody>
@@ -6705,7 +6705,7 @@
                 </a:solidFill>
                 <a:latin typeface="Calibri"/>
               </a:rPr>
-              <a:t>40</a:t>
+              <a:t>2,811</a:t>
             </a:r>
           </a:p>
         </p:txBody>
@@ -6744,7 +6744,7 @@
                 </a:solidFill>
                 <a:latin typeface="Calibri"/>
               </a:rPr>
-              <a:t>exam and college rows</a:t>
+              <a:t>college routes</a:t>
             </a:r>
           </a:p>
         </p:txBody>
@@ -6831,7 +6831,7 @@
                 </a:solidFill>
                 <a:latin typeface="Calibri"/>
               </a:rPr>
-              <a:t>3</a:t>
+              <a:t>8</a:t>
             </a:r>
           </a:p>
         </p:txBody>
@@ -6870,7 +6870,7 @@
                 </a:solidFill>
                 <a:latin typeface="Calibri"/>
               </a:rPr>
-              <a:t>official scholarships</a:t>
+              <a:t>career areas</a:t>
             </a:r>
           </a:p>
         </p:txBody>
@@ -7083,7 +7083,7 @@
                 </a:solidFill>
                 <a:latin typeface="Calibri"/>
               </a:rPr>
-              <a:t>135</a:t>
+              <a:t>161</a:t>
             </a:r>
           </a:p>
         </p:txBody>
@@ -8406,7 +8406,7 @@
                 </a:solidFill>
                 <a:latin typeface="Calibri"/>
               </a:rPr>
-              <a:t>39 of 40 college fee rows are estimates awaiting official fee notices</a:t>
+              <a:t>68 of 355 colleges have an official fee document; the rest are portal figures or group estimates, all flagged</a:t>
             </a:r>
           </a:p>
           <a:p>
@@ -8456,7 +8456,7 @@
                 </a:solidFill>
                 <a:latin typeface="Calibri"/>
               </a:rPr>
-              <a:t>13 careers so far; some have fewer than 3 degree routes</a:t>
+              <a:t>NDA, Environmental Science and Sports have fewer than 3 college routes</a:t>
             </a:r>
           </a:p>
         </p:txBody>
@@ -8666,7 +8666,7 @@
                 </a:solidFill>
                 <a:latin typeface="Calibri"/>
               </a:rPr>
-              <a:t>More careers in each of the 8 areas</a:t>
+              <a:t>Tier 3 fees from each state's fee regulator (Maharashtra FRA, TAFRC)</a:t>
             </a:r>
           </a:p>
         </p:txBody>
@@ -10580,7 +10580,7 @@
                 </a:solidFill>
                 <a:latin typeface="Calibri"/>
               </a:rPr>
-              <a:t>Creates an account and picks a few preferences</a:t>
+              <a:t>Picks their Class 11-12 stream (PCM, PCB, PCMB, Commerce, Arts or not decided) and a few preferences</a:t>
             </a:r>
           </a:p>
           <a:p>
@@ -11389,7 +11389,7 @@
                 </a:solidFill>
                 <a:latin typeface="Calibri"/>
               </a:rPr>
-              <a:t>Ranked list with score, affordable or over budget, and demand. Detail: path, entrance exams, colleges, scholarships and a plain-language explanation.</a:t>
+              <a:t>Ranked list from the student's own stream first, with score, affordability and demand. Detail: path, exams, colleges by NIRF tier, scholarships and an explanation.</a:t>
             </a:r>
           </a:p>
         </p:txBody>
@@ -14713,7 +14713,7 @@
                 </a:solidFill>
                 <a:latin typeface="Calibri"/>
               </a:rPr>
-              <a:t>Weights must sum to 1 (else a 422 error); the sliders change them and the list re-ranks</a:t>
+              <a:t>Own-stream careers always rank first: a PCM student never sees CA or BBA above an engineering career; careers they can't enter are left out</a:t>
             </a:r>
           </a:p>
           <a:p>
@@ -14738,7 +14738,7 @@
                 </a:solidFill>
                 <a:latin typeface="Calibri"/>
               </a:rPr>
-              <a:t>Affordable careers fill the top 5 first; ties break on fit, then market, then id, so results never flip between runs</a:t>
+              <a:t>Weights must sum to 1 (else a 422 error); the sliders re-rank. Affordable first, then fit, market and id break ties</a:t>
             </a:r>
           </a:p>
         </p:txBody>
@@ -15061,6 +15061,31 @@
                 <a:latin typeface="Consolas"/>
               </a:rPr>
               <a:t>= (fee + living) × years − scholarships</a:t>
+            </a:r>
+          </a:p>
+          <a:p>
+            <a:pPr algn="l">
+              <a:spcAft>
+                <a:spcPts val="600"/>
+              </a:spcAft>
+            </a:pPr>
+            <a:r>
+              <a:rPr sz="1300" b="0">
+                <a:solidFill>
+                  <a:srgbClr val="9C9D95"/>
+                </a:solidFill>
+                <a:latin typeface="Consolas"/>
+              </a:rPr>
+              <a:t>          </a:t>
+            </a:r>
+            <a:r>
+              <a:rPr sz="1300" b="0">
+                <a:solidFill>
+                  <a:srgbClr val="9C9D95"/>
+                </a:solidFill>
+                <a:latin typeface="Calibri"/>
+              </a:rPr>
+              <a:t>at a typical college: the median fee, in your state</a:t>
             </a:r>
           </a:p>
           <a:p>

</xml_diff>